<commit_message>
Plantilla E2: nomenclatura de resultados alineada con el deck (resultado intermedio, resultado; sin 'final' ni 'impacto' en la cadena)
Co-Authored-By: Claude Opus 5.5 <noreply@anthropic.com>
</commit_message>
<xml_diff>
--- a/plantilla-entrega-2.pptx
+++ b/plantilla-entrega-2.pptx
@@ -1818,6 +1818,10 @@
             <a:prstDash val="solid"/>
           </a:ln>
         </p:spPr>
+        <p:txBody>
+          <a:bodyPr/>
+          <a:p/>
+        </p:txBody>
       </p:sp>
       <p:sp>
         <p:nvSpPr>
@@ -1946,6 +1950,10 @@
             <a:prstDash val="solid"/>
           </a:ln>
         </p:spPr>
+        <p:txBody>
+          <a:bodyPr/>
+          <a:p/>
+        </p:txBody>
       </p:sp>
       <p:sp>
         <p:nvSpPr>
@@ -2074,6 +2082,10 @@
             <a:prstDash val="solid"/>
           </a:ln>
         </p:spPr>
+        <p:txBody>
+          <a:bodyPr/>
+          <a:p/>
+        </p:txBody>
       </p:sp>
       <p:sp>
         <p:nvSpPr>
@@ -2347,7 +2359,7 @@
                 <a:ea typeface="Cambria" pitchFamily="34" charset="-122"/>
                 <a:cs typeface="Cambria" pitchFamily="34" charset="-120"/>
               </a:rPr>
-              <a:t>Cómo lo que entrega el programa llega al resultado final</a:t>
+              <a:t>Cómo lo que entrega el programa llega al resultado</a:t>
             </a:r>
             <a:endParaRPr lang="en-US" sz="3000" dirty="0"/>
           </a:p>
@@ -2457,6 +2469,10 @@
             <a:prstDash val="solid"/>
           </a:ln>
         </p:spPr>
+        <p:txBody>
+          <a:bodyPr/>
+          <a:p/>
+        </p:txBody>
       </p:sp>
       <p:sp>
         <p:nvSpPr>
@@ -2582,6 +2598,10 @@
             <a:tailEnd type="triangle"/>
           </a:ln>
         </p:spPr>
+        <p:txBody>
+          <a:bodyPr/>
+          <a:p/>
+        </p:txBody>
       </p:sp>
       <p:sp>
         <p:nvSpPr>
@@ -2609,6 +2629,10 @@
             <a:prstDash val="solid"/>
           </a:ln>
         </p:spPr>
+        <p:txBody>
+          <a:bodyPr/>
+          <a:p/>
+        </p:txBody>
       </p:sp>
       <p:sp>
         <p:nvSpPr>
@@ -2685,7 +2709,7 @@
                 <a:ea typeface="Calibri" pitchFamily="34" charset="-122"/>
                 <a:cs typeface="Calibri" pitchFamily="34" charset="-120"/>
               </a:rPr>
-              <a:t>Qué cambia en la conducta o la condición inmediata de quien recibe el producto.</a:t>
+              <a:t>Qué hace o vive distinto quien recibe el producto (su conducta o su situación).</a:t>
             </a:r>
             <a:endParaRPr lang="en-US" sz="1500" dirty="0"/>
           </a:p>
@@ -2714,6 +2738,10 @@
             <a:tailEnd type="triangle"/>
           </a:ln>
         </p:spPr>
+        <p:txBody>
+          <a:bodyPr/>
+          <a:p/>
+        </p:txBody>
       </p:sp>
       <p:sp>
         <p:nvSpPr>
@@ -2741,6 +2769,10 @@
             <a:prstDash val="solid"/>
           </a:ln>
         </p:spPr>
+        <p:txBody>
+          <a:bodyPr/>
+          <a:p/>
+        </p:txBody>
       </p:sp>
       <p:sp>
         <p:nvSpPr>
@@ -2775,7 +2807,7 @@
                 <a:ea typeface="Calibri" pitchFamily="34" charset="-122"/>
                 <a:cs typeface="Calibri" pitchFamily="34" charset="-120"/>
               </a:rPr>
-              <a:t>RESULTADO FINAL</a:t>
+              <a:t>RESULTADO</a:t>
             </a:r>
             <a:endParaRPr lang="en-US" sz="1100" dirty="0"/>
           </a:p>
@@ -2817,7 +2849,7 @@
                 <a:ea typeface="Calibri" pitchFamily="34" charset="-122"/>
                 <a:cs typeface="Calibri" pitchFamily="34" charset="-120"/>
               </a:rPr>
-              <a:t>Qué mejora en la condición de interés.</a:t>
+              <a:t>Qué cambia en la condición de interés.</a:t>
             </a:r>
             <a:endParaRPr lang="en-US" sz="1500" dirty="0"/>
           </a:p>
@@ -3115,6 +3147,10 @@
             <a:prstDash val="solid"/>
           </a:ln>
         </p:spPr>
+        <p:txBody>
+          <a:bodyPr/>
+          <a:p/>
+        </p:txBody>
       </p:sp>
       <p:sp>
         <p:nvSpPr>
@@ -3249,6 +3285,10 @@
             <a:tailEnd type="triangle"/>
           </a:ln>
         </p:spPr>
+        <p:txBody>
+          <a:bodyPr/>
+          <a:p/>
+        </p:txBody>
       </p:sp>
       <p:sp>
         <p:nvSpPr>
@@ -3276,6 +3316,10 @@
             <a:prstDash val="solid"/>
           </a:ln>
         </p:spPr>
+        <p:txBody>
+          <a:bodyPr/>
+          <a:p/>
+        </p:txBody>
       </p:sp>
       <p:sp>
         <p:nvSpPr>
@@ -4163,7 +4207,7 @@
                           <a:ea typeface="Calibri" pitchFamily="34" charset="-122"/>
                           <a:cs typeface="Calibri" pitchFamily="34" charset="-120"/>
                         </a:rPr>
-                        <a:t>Insumo, proceso, producto, resultado o impacto</a:t>
+                        <a:t>Insumo, proceso, producto, resultado intermedio o resultado</a:t>
                       </a:r>
                       <a:endParaRPr lang="en-US" sz="1300" dirty="0">
                         <a:latin typeface="Calibri" charset="0"/>
@@ -6516,6 +6560,10 @@
             <a:prstDash val="solid"/>
           </a:ln>
         </p:spPr>
+        <p:txBody>
+          <a:bodyPr/>
+          <a:p/>
+        </p:txBody>
       </p:sp>
       <p:sp>
         <p:nvSpPr>
@@ -6653,6 +6701,10 @@
             <a:prstDash val="solid"/>
           </a:ln>
         </p:spPr>
+        <p:txBody>
+          <a:bodyPr/>
+          <a:p/>
+        </p:txBody>
       </p:sp>
       <p:sp>
         <p:nvSpPr>

</xml_diff>